<commit_message>
Natural Gas Prices Forecasting Project
</commit_message>
<xml_diff>
--- a/Project/BusinessForecasting_Project.pptx
+++ b/Project/BusinessForecasting_Project.pptx
@@ -4580,7 +4580,7 @@
         </p:spPr>
         <p:txBody>
           <a:bodyPr>
-            <a:normAutofit/>
+            <a:normAutofit fontScale="92500" lnSpcReduction="10000"/>
           </a:bodyPr>
           <a:lstStyle/>
           <a:p>
@@ -4661,6 +4661,16 @@
             <a:r>
               <a:rPr lang="en-US" sz="2400" dirty="0"/>
               <a:t>Forecast for August 2021 (1 year): $2.30</a:t>
+            </a:r>
+          </a:p>
+          <a:p>
+            <a:pPr>
+              <a:buFont typeface="Wingdings" pitchFamily="2" charset="2"/>
+              <a:buChar char="Ø"/>
+            </a:pPr>
+            <a:r>
+              <a:rPr lang="en-US" sz="2400" dirty="0"/>
+              <a:t> 2 year ahead: trend is expected to decrease, and seasonality is expected to be variable yet weak</a:t>
             </a:r>
           </a:p>
         </p:txBody>
@@ -4897,7 +4907,7 @@
             </a:pPr>
             <a:r>
               <a:rPr lang="en-US" sz="2600" dirty="0"/>
-              <a:t>Distribution &amp; Skewness: series is right-skewed, and variability increases from year to year. </a:t>
+              <a:t>Distribution &amp; Skewness: series is right-skewed</a:t>
             </a:r>
           </a:p>
           <a:p>
@@ -5006,7 +5016,7 @@
         </p:spPr>
         <p:txBody>
           <a:bodyPr>
-            <a:normAutofit fontScale="92500" lnSpcReduction="20000"/>
+            <a:normAutofit fontScale="92500" lnSpcReduction="10000"/>
           </a:bodyPr>
           <a:lstStyle/>
           <a:p>
@@ -5026,7 +5036,7 @@
             </a:pPr>
             <a:r>
               <a:rPr lang="en-US" sz="1900" dirty="0"/>
-              <a:t>Add meaningful features like weather, demand levels, storage levels, geopolitical issues</a:t>
+              <a:t>Add meaningful features like weather, demand levels, storage levels, geopolitical issues/policies</a:t>
             </a:r>
           </a:p>
           <a:p>
@@ -5052,7 +5062,7 @@
             </a:r>
             <a:r>
               <a:rPr lang="en-US" sz="1900" dirty="0"/>
-              <a:t>, Random Forest Regression, Gradient Boosting, ARIMAX (ARIMA with external regressors), Vector Autoregression with exogenous input (VARX) or neural networks</a:t>
+              <a:t>, Random Forest Regression, Gradient Boosting, ARIMAX (ARIMA with external features), Vector Autoregression with external features (VARX) or neural networks</a:t>
             </a:r>
           </a:p>
           <a:p>
@@ -5082,7 +5092,7 @@
             </a:pPr>
             <a:r>
               <a:rPr lang="en-US" sz="2000" dirty="0"/>
-              <a:t>Transform data: forecast difference in price or log-returns instead of level and then reconstruct the level</a:t>
+              <a:t>Transform data: forecast difference in price or log-returns and then reconstruct the level</a:t>
             </a:r>
           </a:p>
           <a:p>
@@ -5102,7 +5112,7 @@
             </a:pPr>
             <a:r>
               <a:rPr lang="en-US" sz="2200" dirty="0"/>
-              <a:t>Hybrid/ensemble strategies</a:t>
+              <a:t>Hybrid strategies</a:t>
             </a:r>
           </a:p>
           <a:p>
@@ -5305,7 +5315,7 @@
             </a:pPr>
             <a:r>
               <a:rPr lang="en-US" dirty="0"/>
-              <a:t>The natural gas market is considered seasonal with dual seasonal peaks where annual seasonality is observed in winter, and secondary seasonal peak is observed in summer. There is also an economic element in the natural gas market especially with the adoption of EV cars and heighten geopolitical issues in the recent years. </a:t>
+              <a:t>The natural gas market is considered seasonal with dual seasonal peaks where annual seasonality is observed in winter, and secondary seasonal peak is observed in summer. There is also an economic element in the natural gas market especially with renewable energy adoption and geopolitical shifts.</a:t>
             </a:r>
           </a:p>
           <a:p>
@@ -5350,7 +5360,7 @@
             </a:pPr>
             <a:r>
               <a:rPr lang="en-US" altLang="en-US" dirty="0"/>
-              <a:t>Electricity Market Planning: electricity market forecasting</a:t>
+              <a:t>Electricity Market Planning</a:t>
             </a:r>
           </a:p>
           <a:p>
@@ -5560,7 +5570,7 @@
             </a:pPr>
             <a:r>
               <a:rPr lang="en-US" dirty="0"/>
-              <a:t>Storage levels cause massive market shocks (pipeline outages, export/import constraints, etc.)</a:t>
+              <a:t>Storage levels, pipeline outages, export/import constraints cause massive market shocks</a:t>
             </a:r>
           </a:p>
           <a:p>
@@ -5570,7 +5580,7 @@
             </a:pPr>
             <a:r>
               <a:rPr lang="en-US" dirty="0"/>
-              <a:t>Nonlinear relationships in terms of supply and demand</a:t>
+              <a:t>Nonlinear relationships in terms of supply, demand, and production </a:t>
             </a:r>
           </a:p>
           <a:p>
@@ -5683,7 +5693,7 @@
             </a:pPr>
             <a:r>
               <a:rPr lang="en-US" sz="2000" dirty="0"/>
-              <a:t> Accuracy Measure Used for the Model Analysis: MAPE (Mean Absolute   Percentage Error)</a:t>
+              <a:t> Accuracy Measure Used for the Model Analysis: MAPE </a:t>
             </a:r>
           </a:p>
           <a:p>
@@ -5723,6 +5733,12 @@
             <a:endParaRPr lang="en-US" dirty="0"/>
           </a:p>
           <a:p>
+            <a:pPr marL="246888" lvl="1" indent="0">
+              <a:buNone/>
+            </a:pPr>
+            <a:endParaRPr lang="en-US" dirty="0"/>
+          </a:p>
+          <a:p>
             <a:pPr>
               <a:buFont typeface="Wingdings" pitchFamily="2" charset="2"/>
               <a:buChar char="Ø"/>
@@ -5745,22 +5761,15 @@
           <a:p>
             <a:pPr lvl="2"/>
             <a:r>
-              <a:rPr lang="en-US" sz="1600" dirty="0"/>
+              <a:rPr lang="en-US" sz="1800" dirty="0"/>
               <a:t>Moving Average model as the orders go up became equivalent to Naïve Model</a:t>
             </a:r>
           </a:p>
           <a:p>
             <a:pPr lvl="2"/>
             <a:r>
-              <a:rPr lang="en-US" sz="1600" dirty="0"/>
-              <a:t>Random Walk, Simple Exponential Smoothing, ARIMA produced similar MAPEs</a:t>
-            </a:r>
-          </a:p>
-          <a:p>
-            <a:pPr lvl="2"/>
-            <a:r>
-              <a:rPr lang="en-US" sz="1600" dirty="0"/>
-              <a:t>Cost efficient and simple in terms of industry usage</a:t>
+              <a:rPr lang="en-US" sz="1800" dirty="0"/>
+              <a:t>Random Walk, Simple Exponential Smoothing, ARIMA produced similar MAPE</a:t>
             </a:r>
           </a:p>
         </p:txBody>
@@ -6508,7 +6517,7 @@
             </a:pPr>
             <a:r>
               <a:rPr lang="en-US" sz="1800" dirty="0"/>
-              <a:t>Declines at a faster pace prior to falling below the significant line.</a:t>
+              <a:t>Declines prior to falling below the significant line.</a:t>
             </a:r>
           </a:p>
           <a:p>
@@ -6723,7 +6732,7 @@
             </a:pPr>
             <a:r>
               <a:rPr lang="en-US" dirty="0"/>
-              <a:t>Has tiny amplitude (small highs/lows)</a:t>
+              <a:t>Has smaller amplitude (highs/lows)</a:t>
             </a:r>
           </a:p>
           <a:p>
@@ -6753,7 +6762,7 @@
             </a:pPr>
             <a:r>
               <a:rPr lang="en-US" dirty="0"/>
-              <a:t>Increasing and decreasing pattern is observed with an overall decreasing trend</a:t>
+              <a:t>Increasing and decreasing pattern over specific time intervals with an overall decreasing trend</a:t>
             </a:r>
           </a:p>
           <a:p>
@@ -6850,7 +6859,7 @@
         </p:nvCxnSpPr>
         <p:spPr>
           <a:xfrm>
-            <a:off x="9952362" y="1839817"/>
+            <a:off x="9930059" y="1806363"/>
             <a:ext cx="275422" cy="0"/>
           </a:xfrm>
           <a:prstGeom prst="straightConnector1">

</xml_diff>